<commit_message>
docs: Ajoute les diagrammes UML en annexe et corrige la diapositive des limites
Ajoute une section ANNEXES (6 diapositives) au support de soutenance avec
5 diagrammes de classes conceptuels (vue d'ensemble, identités/sécurité,
LMD, évaluations polymorphes, emploi du temps), dans le style exact du
reste du deck. Diagramme "Analytics" volontairement écarté (trop
générique comparé à l'implémentation réelle).

Met à jour la diapositive "Limites & perspectives" avec l'état réel après
durcissement : Mobile Money/push étaient déjà opérationnels (diapositive
obsolète), bug prédictif corrigé, test de charge réel exécuté, RLS
implémentée et testée.

Ajoute la note de conception pour un futur passage multi-tenant
(trajectoire concrète, hors scope d'implémentation pour ce mémoire).

Co-Authored-By: Claude Sonnet 5 <noreply@anthropic.com>
</commit_message>
<xml_diff>
--- a/TIRAHOU_Soutenance.pptx
+++ b/TIRAHOU_Soutenance.pptx
@@ -30,6 +30,12 @@
     <p:sldId id="278" r:id="rId29"/>
     <p:sldId id="279" r:id="rId30"/>
     <p:sldId id="280" r:id="rId31"/>
+    <p:sldId id="281" r:id="rId32"/>
+    <p:sldId id="282" r:id="rId33"/>
+    <p:sldId id="283" r:id="rId34"/>
+    <p:sldId id="284" r:id="rId35"/>
+    <p:sldId id="285" r:id="rId36"/>
+    <p:sldId id="286" r:id="rId37"/>
   </p:sldIdLst>
   <p:sldSz cx="12191695" cy="6858000" type="screen4x3"/>
   <p:notesSz cx="6858000" cy="9144000"/>
@@ -20854,7 +20860,7 @@
                 </a:solidFill>
                 <a:latin typeface="Segoe UI"/>
               </a:rPr>
-              <a:t>Limites identifiées</a:t>
+              <a:t>Limites traitées pendant la préparation</a:t>
             </a:r>
           </a:p>
         </p:txBody>
@@ -20905,7 +20911,7 @@
                 </a:solidFill>
                 <a:latin typeface="Segoe UI"/>
               </a:rPr>
-              <a:t>Mobile Money enregistré manuellement (pas d'API CinetPay/FedaPay)</a:t>
+              <a:t>Mobile Money (CinetPay) &amp; notifications push : déjà opérationnels de bout en bout</a:t>
             </a:r>
           </a:p>
           <a:p>
@@ -20933,7 +20939,7 @@
                 </a:solidFill>
                 <a:latin typeface="Segoe UI"/>
               </a:rPr>
-              <a:t>Modèle de prédiction heuristique, non calibré sur données réelles</a:t>
+              <a:t>Bug critique corrigé sur le score prédictif + calibration empirique outillée</a:t>
             </a:r>
           </a:p>
           <a:p>
@@ -20961,7 +20967,7 @@
                 </a:solidFill>
                 <a:latin typeface="Segoe UI"/>
               </a:rPr>
-              <a:t>Aucun test de charge réalisé (comportement sous forte affluence inconnu)</a:t>
+              <a:t>Test de charge réel exécuté (40 util.) — rate limiting confirmé, latence de connexion identifiée</a:t>
             </a:r>
           </a:p>
           <a:p>
@@ -20989,9 +20995,71 @@
                 </a:solidFill>
                 <a:latin typeface="Segoe UI"/>
               </a:rPr>
-              <a:t>Row-Level Security absent (filtrage au niveau vue, pas natif DB)</a:t>
-            </a:r>
-          </a:p>
+              <a:t>Row-Level Security PostgreSQL implémentée et testée (défense en profondeur)</a:t>
+            </a:r>
+          </a:p>
+        </p:txBody>
+      </p:sp>
+      <p:sp>
+        <p:nvSpPr>
+          <p:cNvPr id="11" name="TextBox 10"/>
+          <p:cNvSpPr txBox="1"/>
+          <p:nvPr/>
+        </p:nvSpPr>
+        <p:spPr>
+          <a:xfrm>
+            <a:off x="6263640" y="1828800"/>
+            <a:ext cx="5212080" cy="365760"/>
+          </a:xfrm>
+          <a:prstGeom prst="rect">
+            <a:avLst/>
+          </a:prstGeom>
+          <a:noFill/>
+        </p:spPr>
+        <p:txBody>
+          <a:bodyPr wrap="square" anchor="t" lIns="0" rIns="0" tIns="0" bIns="0">
+            <a:spAutoFit/>
+          </a:bodyPr>
+          <a:lstStyle/>
+          <a:p>
+            <a:pPr algn="l">
+              <a:lnSpc>
+                <a:spcPct val="100000"/>
+              </a:lnSpc>
+            </a:pPr>
+            <a:r>
+              <a:rPr sz="1400" b="1" i="0">
+                <a:solidFill>
+                  <a:srgbClr val="059669"/>
+                </a:solidFill>
+                <a:latin typeface="Segoe UI"/>
+              </a:rPr>
+              <a:t>Perspectives d'évolution</a:t>
+            </a:r>
+          </a:p>
+        </p:txBody>
+      </p:sp>
+      <p:sp>
+        <p:nvSpPr>
+          <p:cNvPr id="12" name="TextBox 11"/>
+          <p:cNvSpPr txBox="1"/>
+          <p:nvPr/>
+        </p:nvSpPr>
+        <p:spPr>
+          <a:xfrm>
+            <a:off x="6263640" y="2240280"/>
+            <a:ext cx="5212080" cy="3840480"/>
+          </a:xfrm>
+          <a:prstGeom prst="rect">
+            <a:avLst/>
+          </a:prstGeom>
+          <a:noFill/>
+        </p:spPr>
+        <p:txBody>
+          <a:bodyPr wrap="square" lIns="0" rIns="0">
+            <a:spAutoFit/>
+          </a:bodyPr>
+          <a:lstStyle/>
           <a:p>
             <a:pPr>
               <a:lnSpc>
@@ -21004,20 +21072,29 @@
             <a:r>
               <a:rPr sz="900">
                 <a:solidFill>
-                  <a:srgbClr val="DC2626"/>
+                  <a:srgbClr val="059669"/>
                 </a:solidFill>
                 <a:latin typeface="Segoe UI"/>
               </a:rPr>
               <a:t>●  </a:t>
             </a:r>
             <a:r>
+              <a:rPr b="1" sz="1200">
+                <a:solidFill>
+                  <a:srgbClr val="0F172A"/>
+                </a:solidFill>
+                <a:latin typeface="Segoe UI"/>
+              </a:rPr>
+              <a:t>Court terme — </a:t>
+            </a:r>
+            <a:r>
               <a:rPr sz="1200">
                 <a:solidFill>
                   <a:srgbClr val="334155"/>
                 </a:solidFill>
                 <a:latin typeface="Segoe UI"/>
               </a:rPr>
-              <a:t>Notifications push non implémentées (PWA prête, non activée)</a:t>
+              <a:t>recalibrer le modèle prédictif sur des données réelles de production</a:t>
             </a:r>
           </a:p>
           <a:p>
@@ -21032,156 +21109,29 @@
             <a:r>
               <a:rPr sz="900">
                 <a:solidFill>
-                  <a:srgbClr val="DC2626"/>
+                  <a:srgbClr val="059669"/>
                 </a:solidFill>
                 <a:latin typeface="Segoe UI"/>
               </a:rPr>
               <a:t>●  </a:t>
             </a:r>
             <a:r>
+              <a:rPr b="1" sz="1200">
+                <a:solidFill>
+                  <a:srgbClr val="0F172A"/>
+                </a:solidFill>
+                <a:latin typeface="Segoe UI"/>
+              </a:rPr>
+              <a:t>Moyen terme — </a:t>
+            </a:r>
+            <a:r>
               <a:rPr sz="1200">
                 <a:solidFill>
                   <a:srgbClr val="334155"/>
                 </a:solidFill>
                 <a:latin typeface="Segoe UI"/>
               </a:rPr>
-              <a:t>Architecture mono-établissement, pas encore multi-tenant</a:t>
-            </a:r>
-          </a:p>
-        </p:txBody>
-      </p:sp>
-      <p:sp>
-        <p:nvSpPr>
-          <p:cNvPr id="11" name="TextBox 10"/>
-          <p:cNvSpPr txBox="1"/>
-          <p:nvPr/>
-        </p:nvSpPr>
-        <p:spPr>
-          <a:xfrm>
-            <a:off x="6263640" y="1828800"/>
-            <a:ext cx="5212080" cy="365760"/>
-          </a:xfrm>
-          <a:prstGeom prst="rect">
-            <a:avLst/>
-          </a:prstGeom>
-          <a:noFill/>
-        </p:spPr>
-        <p:txBody>
-          <a:bodyPr wrap="square" anchor="t" lIns="0" rIns="0" tIns="0" bIns="0">
-            <a:spAutoFit/>
-          </a:bodyPr>
-          <a:lstStyle/>
-          <a:p>
-            <a:pPr algn="l">
-              <a:lnSpc>
-                <a:spcPct val="100000"/>
-              </a:lnSpc>
-            </a:pPr>
-            <a:r>
-              <a:rPr sz="1400" b="1" i="0">
-                <a:solidFill>
-                  <a:srgbClr val="059669"/>
-                </a:solidFill>
-                <a:latin typeface="Segoe UI"/>
-              </a:rPr>
-              <a:t>Perspectives d'évolution</a:t>
-            </a:r>
-          </a:p>
-        </p:txBody>
-      </p:sp>
-      <p:sp>
-        <p:nvSpPr>
-          <p:cNvPr id="12" name="TextBox 11"/>
-          <p:cNvSpPr txBox="1"/>
-          <p:nvPr/>
-        </p:nvSpPr>
-        <p:spPr>
-          <a:xfrm>
-            <a:off x="6263640" y="2240280"/>
-            <a:ext cx="5212080" cy="3840480"/>
-          </a:xfrm>
-          <a:prstGeom prst="rect">
-            <a:avLst/>
-          </a:prstGeom>
-          <a:noFill/>
-        </p:spPr>
-        <p:txBody>
-          <a:bodyPr wrap="square" lIns="0" rIns="0">
-            <a:spAutoFit/>
-          </a:bodyPr>
-          <a:lstStyle/>
-          <a:p>
-            <a:pPr>
-              <a:lnSpc>
-                <a:spcPct val="108000"/>
-              </a:lnSpc>
-              <a:spcAft>
-                <a:spcPts val="1000"/>
-              </a:spcAft>
-            </a:pPr>
-            <a:r>
-              <a:rPr sz="900">
-                <a:solidFill>
-                  <a:srgbClr val="059669"/>
-                </a:solidFill>
-                <a:latin typeface="Segoe UI"/>
-              </a:rPr>
-              <a:t>●  </a:t>
-            </a:r>
-            <a:r>
-              <a:rPr b="1" sz="1200">
-                <a:solidFill>
-                  <a:srgbClr val="0F172A"/>
-                </a:solidFill>
-                <a:latin typeface="Segoe UI"/>
-              </a:rPr>
-              <a:t>Court terme — </a:t>
-            </a:r>
-            <a:r>
-              <a:rPr sz="1200">
-                <a:solidFill>
-                  <a:srgbClr val="334155"/>
-                </a:solidFill>
-                <a:latin typeface="Segoe UI"/>
-              </a:rPr>
-              <a:t>paiements Mobile Money via API, notifications push, tests de charge (Locust)</a:t>
-            </a:r>
-          </a:p>
-          <a:p>
-            <a:pPr>
-              <a:lnSpc>
-                <a:spcPct val="108000"/>
-              </a:lnSpc>
-              <a:spcAft>
-                <a:spcPts val="1000"/>
-              </a:spcAft>
-            </a:pPr>
-            <a:r>
-              <a:rPr sz="900">
-                <a:solidFill>
-                  <a:srgbClr val="059669"/>
-                </a:solidFill>
-                <a:latin typeface="Segoe UI"/>
-              </a:rPr>
-              <a:t>●  </a:t>
-            </a:r>
-            <a:r>
-              <a:rPr b="1" sz="1200">
-                <a:solidFill>
-                  <a:srgbClr val="0F172A"/>
-                </a:solidFill>
-                <a:latin typeface="Segoe UI"/>
-              </a:rPr>
-              <a:t>Moyen terme — </a:t>
-            </a:r>
-            <a:r>
-              <a:rPr sz="1200">
-                <a:solidFill>
-                  <a:srgbClr val="334155"/>
-                </a:solidFill>
-                <a:latin typeface="Segoe UI"/>
-              </a:rPr>
-              <a:t>modèle ML supervisé, architecture multi-tenant (SaaS), module RH &amp; paie, SCORM/xAPI</a:t>
+              <a:t>architecture multi-tenant (note de conception rédigée), module RH &amp; paie, SCORM/xAPI</a:t>
             </a:r>
           </a:p>
           <a:p>
@@ -21633,6 +21583,1579 @@
 </p:sld>
 </file>
 
+<file path=ppt/slides/slide26.xml><?xml version="1.0" encoding="utf-8"?>
+<p:sld xmlns:a="http://schemas.openxmlformats.org/drawingml/2006/main" xmlns:p="http://schemas.openxmlformats.org/presentationml/2006/main" xmlns:r="http://schemas.openxmlformats.org/officeDocument/2006/relationships">
+  <p:cSld>
+    <p:spTree>
+      <p:nvGrpSpPr>
+        <p:cNvPr id="1" name=""/>
+        <p:cNvGrpSpPr/>
+        <p:nvPr/>
+      </p:nvGrpSpPr>
+      <p:grpSpPr/>
+      <p:sp>
+        <p:nvSpPr>
+          <p:cNvPr id="2" name="Rectangle 1"/>
+          <p:cNvSpPr/>
+          <p:nvPr/>
+        </p:nvSpPr>
+        <p:spPr>
+          <a:xfrm>
+            <a:off x="0" y="0"/>
+            <a:ext cx="12191695" cy="6858000"/>
+          </a:xfrm>
+          <a:prstGeom prst="rect">
+            <a:avLst/>
+          </a:prstGeom>
+          <a:solidFill>
+            <a:srgbClr val="F8FAFC"/>
+          </a:solidFill>
+          <a:ln>
+            <a:noFill/>
+          </a:ln>
+          <a:effectLst/>
+        </p:spPr>
+        <p:style>
+          <a:lnRef idx="1">
+            <a:schemeClr val="accent1"/>
+          </a:lnRef>
+          <a:fillRef idx="3">
+            <a:schemeClr val="accent1"/>
+          </a:fillRef>
+          <a:effectRef idx="2">
+            <a:schemeClr val="accent1"/>
+          </a:effectRef>
+          <a:fontRef idx="minor">
+            <a:schemeClr val="lt1"/>
+          </a:fontRef>
+        </p:style>
+        <p:txBody>
+          <a:bodyPr rtlCol="0" anchor="ctr"/>
+          <a:lstStyle/>
+          <a:p>
+            <a:pPr algn="ctr"/>
+          </a:p>
+        </p:txBody>
+      </p:sp>
+      <p:sp>
+        <p:nvSpPr>
+          <p:cNvPr id="3" name="Rectangle 2"/>
+          <p:cNvSpPr/>
+          <p:nvPr/>
+        </p:nvSpPr>
+        <p:spPr>
+          <a:xfrm>
+            <a:off x="502920" y="457200"/>
+            <a:ext cx="54864" cy="777240"/>
+          </a:xfrm>
+          <a:prstGeom prst="rect">
+            <a:avLst/>
+          </a:prstGeom>
+          <a:solidFill>
+            <a:srgbClr val="2563EB"/>
+          </a:solidFill>
+          <a:ln>
+            <a:noFill/>
+          </a:ln>
+          <a:effectLst/>
+        </p:spPr>
+        <p:style>
+          <a:lnRef idx="1">
+            <a:schemeClr val="accent1"/>
+          </a:lnRef>
+          <a:fillRef idx="3">
+            <a:schemeClr val="accent1"/>
+          </a:fillRef>
+          <a:effectRef idx="2">
+            <a:schemeClr val="accent1"/>
+          </a:effectRef>
+          <a:fontRef idx="minor">
+            <a:schemeClr val="lt1"/>
+          </a:fontRef>
+        </p:style>
+        <p:txBody>
+          <a:bodyPr rtlCol="0" anchor="ctr"/>
+          <a:lstStyle/>
+          <a:p>
+            <a:pPr algn="ctr"/>
+          </a:p>
+        </p:txBody>
+      </p:sp>
+      <p:sp>
+        <p:nvSpPr>
+          <p:cNvPr id="4" name="TextBox 3"/>
+          <p:cNvSpPr txBox="1"/>
+          <p:nvPr/>
+        </p:nvSpPr>
+        <p:spPr>
+          <a:xfrm>
+            <a:off x="713232" y="438912"/>
+            <a:ext cx="10058400" cy="274320"/>
+          </a:xfrm>
+          <a:prstGeom prst="rect">
+            <a:avLst/>
+          </a:prstGeom>
+          <a:noFill/>
+        </p:spPr>
+        <p:txBody>
+          <a:bodyPr wrap="none" lIns="0" tIns="0" rIns="0" bIns="0">
+            <a:spAutoFit/>
+          </a:bodyPr>
+          <a:lstStyle/>
+          <a:p>
+            <a:pPr algn="l"/>
+            <a:r>
+              <a:rPr sz="1150" b="1">
+                <a:solidFill>
+                  <a:srgbClr val="2563EB"/>
+                </a:solidFill>
+                <a:latin typeface="Segoe UI"/>
+              </a:rPr>
+              <a:t>ANNEXES</a:t>
+            </a:r>
+          </a:p>
+        </p:txBody>
+      </p:sp>
+      <p:sp>
+        <p:nvSpPr>
+          <p:cNvPr id="5" name="TextBox 4"/>
+          <p:cNvSpPr txBox="1"/>
+          <p:nvPr/>
+        </p:nvSpPr>
+        <p:spPr>
+          <a:xfrm>
+            <a:off x="685800" y="694944"/>
+            <a:ext cx="10789920" cy="594360"/>
+          </a:xfrm>
+          <a:prstGeom prst="rect">
+            <a:avLst/>
+          </a:prstGeom>
+          <a:noFill/>
+        </p:spPr>
+        <p:txBody>
+          <a:bodyPr wrap="square" lIns="0" tIns="0" rIns="0" bIns="0">
+            <a:spAutoFit/>
+          </a:bodyPr>
+          <a:lstStyle/>
+          <a:p>
+            <a:pPr algn="l"/>
+            <a:r>
+              <a:rPr sz="2700" b="1">
+                <a:solidFill>
+                  <a:srgbClr val="0F172A"/>
+                </a:solidFill>
+                <a:latin typeface="Segoe UI Semibold"/>
+              </a:rPr>
+              <a:t>Modélisation UML complémentaire — diagrammes de classes</a:t>
+            </a:r>
+          </a:p>
+        </p:txBody>
+      </p:sp>
+      <p:sp>
+        <p:nvSpPr>
+          <p:cNvPr id="6" name="TextBox 5"/>
+          <p:cNvSpPr txBox="1"/>
+          <p:nvPr/>
+        </p:nvSpPr>
+        <p:spPr>
+          <a:xfrm>
+            <a:off x="502920" y="6528816"/>
+            <a:ext cx="5486400" cy="274320"/>
+          </a:xfrm>
+          <a:prstGeom prst="rect">
+            <a:avLst/>
+          </a:prstGeom>
+          <a:noFill/>
+        </p:spPr>
+        <p:txBody>
+          <a:bodyPr wrap="none" lIns="0" tIns="0" rIns="0" bIns="0">
+            <a:spAutoFit/>
+          </a:bodyPr>
+          <a:lstStyle/>
+          <a:p>
+            <a:r>
+              <a:rPr sz="900">
+                <a:solidFill>
+                  <a:srgbClr val="64748B"/>
+                </a:solidFill>
+                <a:latin typeface="Segoe UI"/>
+              </a:rPr>
+              <a:t>TIRAHOU — Soutenance de mémoire</a:t>
+            </a:r>
+          </a:p>
+        </p:txBody>
+      </p:sp>
+      <p:sp>
+        <p:nvSpPr>
+          <p:cNvPr id="7" name="TextBox 6"/>
+          <p:cNvSpPr txBox="1"/>
+          <p:nvPr/>
+        </p:nvSpPr>
+        <p:spPr>
+          <a:xfrm>
+            <a:off x="10972800" y="6528816"/>
+            <a:ext cx="731520" cy="274320"/>
+          </a:xfrm>
+          <a:prstGeom prst="rect">
+            <a:avLst/>
+          </a:prstGeom>
+          <a:noFill/>
+        </p:spPr>
+        <p:txBody>
+          <a:bodyPr wrap="none" lIns="0" tIns="0" rIns="0" bIns="0">
+            <a:spAutoFit/>
+          </a:bodyPr>
+          <a:lstStyle/>
+          <a:p>
+            <a:pPr algn="r"/>
+            <a:r>
+              <a:rPr sz="900">
+                <a:solidFill>
+                  <a:srgbClr val="64748B"/>
+                </a:solidFill>
+                <a:latin typeface="Segoe UI"/>
+              </a:rPr>
+              <a:t>26</a:t>
+            </a:r>
+          </a:p>
+        </p:txBody>
+      </p:sp>
+      <p:cxnSp>
+        <p:nvCxnSpPr>
+          <p:cNvPr id="8" name="Connector 7"/>
+          <p:cNvCxnSpPr/>
+          <p:nvPr/>
+        </p:nvCxnSpPr>
+        <p:spPr>
+          <a:xfrm>
+            <a:off x="502920" y="6473952"/>
+            <a:ext cx="11183112" cy="0"/>
+          </a:xfrm>
+          <a:prstGeom prst="line">
+            <a:avLst/>
+          </a:prstGeom>
+          <a:ln w="9525">
+            <a:solidFill>
+              <a:srgbClr val="E2E8F0"/>
+            </a:solidFill>
+          </a:ln>
+        </p:spPr>
+        <p:style>
+          <a:lnRef idx="2">
+            <a:schemeClr val="accent1"/>
+          </a:lnRef>
+          <a:fillRef idx="0">
+            <a:schemeClr val="accent1"/>
+          </a:fillRef>
+          <a:effectRef idx="1">
+            <a:schemeClr val="accent1"/>
+          </a:effectRef>
+          <a:fontRef idx="minor">
+            <a:schemeClr val="tx1"/>
+          </a:fontRef>
+        </p:style>
+      </p:cxnSp>
+      <p:sp>
+        <p:nvSpPr>
+          <p:cNvPr id="9" name="TextBox 8"/>
+          <p:cNvSpPr txBox="1"/>
+          <p:nvPr/>
+        </p:nvSpPr>
+        <p:spPr>
+          <a:xfrm>
+            <a:off x="502920" y="1900000"/>
+            <a:ext cx="11183112" cy="3800000"/>
+          </a:xfrm>
+          <a:prstGeom prst="rect">
+            <a:avLst/>
+          </a:prstGeom>
+          <a:noFill/>
+        </p:spPr>
+        <p:txBody>
+          <a:bodyPr wrap="square" lIns="0" tIns="0" rIns="0" bIns="0">
+            <a:spAutoFit/>
+          </a:bodyPr>
+          <a:lstStyle/>
+          <a:p>
+            <a:pPr>
+              <a:spcAft>
+                <a:spcPts val="1000"/>
+              </a:spcAft>
+            </a:pPr>
+            <a:r>
+              <a:rPr sz="1500" b="0">
+                <a:solidFill>
+                  <a:srgbClr val="64748B"/>
+                </a:solidFill>
+                <a:latin typeface="Segoe UI"/>
+              </a:rPr>
+              <a:t>Les diagrammes suivants documentent le modèle conceptuel de classes établi lors de la</a:t>
+            </a:r>
+          </a:p>
+          <a:p>
+            <a:pPr>
+              <a:spcAft>
+                <a:spcPts val="1000"/>
+              </a:spcAft>
+            </a:pPr>
+            <a:r>
+              <a:rPr sz="1500" b="0">
+                <a:solidFill>
+                  <a:srgbClr val="64748B"/>
+                </a:solidFill>
+                <a:latin typeface="Segoe UI"/>
+              </a:rPr>
+              <a:t>phase de conception, avant l'implémentation — ils illustrent la démarche de modélisation</a:t>
+            </a:r>
+          </a:p>
+          <a:p>
+            <a:pPr>
+              <a:spcAft>
+                <a:spcPts val="1000"/>
+              </a:spcAft>
+            </a:pPr>
+            <a:r>
+              <a:rPr sz="1500" b="0">
+                <a:solidFill>
+                  <a:srgbClr val="64748B"/>
+                </a:solidFill>
+                <a:latin typeface="Segoe UI"/>
+              </a:rPr>
+              <a:t>qui a précédé et structuré le développement de chaque module.</a:t>
+            </a:r>
+          </a:p>
+          <a:p>
+            <a:pPr>
+              <a:spcAft>
+                <a:spcPts val="1000"/>
+              </a:spcAft>
+            </a:pPr>
+            <a:r>
+              <a:rPr sz="1500" b="0">
+                <a:solidFill>
+                  <a:srgbClr val="64748B"/>
+                </a:solidFill>
+                <a:latin typeface="Segoe UI"/>
+              </a:rPr>
+              <a:t/>
+            </a:r>
+          </a:p>
+          <a:p>
+            <a:pPr>
+              <a:spcAft>
+                <a:spcPts val="1000"/>
+              </a:spcAft>
+            </a:pPr>
+            <a:r>
+              <a:rPr sz="1600" b="1">
+                <a:solidFill>
+                  <a:srgbClr val="0F172A"/>
+                </a:solidFill>
+                <a:latin typeface="Segoe UI"/>
+              </a:rPr>
+              <a:t>1.  Diagramme de classes global — vue d'ensemble du domaine métier</a:t>
+            </a:r>
+          </a:p>
+          <a:p>
+            <a:pPr>
+              <a:spcAft>
+                <a:spcPts val="1000"/>
+              </a:spcAft>
+            </a:pPr>
+            <a:r>
+              <a:rPr sz="1600" b="1">
+                <a:solidFill>
+                  <a:srgbClr val="0F172A"/>
+                </a:solidFill>
+                <a:latin typeface="Segoe UI"/>
+              </a:rPr>
+              <a:t>2.  Identités &amp; sécurité — utilisateurs, rôles, permissions, sessions, audit</a:t>
+            </a:r>
+          </a:p>
+          <a:p>
+            <a:pPr>
+              <a:spcAft>
+                <a:spcPts val="1000"/>
+              </a:spcAft>
+            </a:pPr>
+            <a:r>
+              <a:rPr sz="1600" b="1">
+                <a:solidFill>
+                  <a:srgbClr val="0F172A"/>
+                </a:solidFill>
+                <a:latin typeface="Segoe UI"/>
+              </a:rPr>
+              <a:t>3.  Structure LMD — niveaux, semestres, UE, EC, crédits</a:t>
+            </a:r>
+          </a:p>
+          <a:p>
+            <a:pPr>
+              <a:spcAft>
+                <a:spcPts val="1000"/>
+              </a:spcAft>
+            </a:pPr>
+            <a:r>
+              <a:rPr sz="1600" b="1">
+                <a:solidFill>
+                  <a:srgbClr val="0F172A"/>
+                </a:solidFill>
+                <a:latin typeface="Segoe UI"/>
+              </a:rPr>
+              <a:t>4.  Évaluations — modèle polymorphe (examen, quiz, devoir, projet)</a:t>
+            </a:r>
+          </a:p>
+          <a:p>
+            <a:pPr>
+              <a:spcAft>
+                <a:spcPts val="1000"/>
+              </a:spcAft>
+            </a:pPr>
+            <a:r>
+              <a:rPr sz="1600" b="1">
+                <a:solidFill>
+                  <a:srgbClr val="0F172A"/>
+                </a:solidFill>
+                <a:latin typeface="Segoe UI"/>
+              </a:rPr>
+              <a:t>5.  Emploi du temps — créneaux, salles, réservations</a:t>
+            </a:r>
+          </a:p>
+        </p:txBody>
+      </p:sp>
+    </p:spTree>
+  </p:cSld>
+  <p:clrMapOvr>
+    <a:masterClrMapping/>
+  </p:clrMapOvr>
+</p:sld>
+</file>
+
+<file path=ppt/slides/slide27.xml><?xml version="1.0" encoding="utf-8"?>
+<p:sld xmlns:a="http://schemas.openxmlformats.org/drawingml/2006/main" xmlns:p="http://schemas.openxmlformats.org/presentationml/2006/main" xmlns:r="http://schemas.openxmlformats.org/officeDocument/2006/relationships">
+  <p:cSld>
+    <p:spTree>
+      <p:nvGrpSpPr>
+        <p:cNvPr id="1" name=""/>
+        <p:cNvGrpSpPr/>
+        <p:nvPr/>
+      </p:nvGrpSpPr>
+      <p:grpSpPr/>
+      <p:sp>
+        <p:nvSpPr>
+          <p:cNvPr id="2" name="Rectangle 1"/>
+          <p:cNvSpPr/>
+          <p:nvPr/>
+        </p:nvSpPr>
+        <p:spPr>
+          <a:xfrm>
+            <a:off x="0" y="0"/>
+            <a:ext cx="12191695" cy="6858000"/>
+          </a:xfrm>
+          <a:prstGeom prst="rect">
+            <a:avLst/>
+          </a:prstGeom>
+          <a:solidFill>
+            <a:srgbClr val="F8FAFC"/>
+          </a:solidFill>
+          <a:ln>
+            <a:noFill/>
+          </a:ln>
+          <a:effectLst/>
+        </p:spPr>
+        <p:style>
+          <a:lnRef idx="1">
+            <a:schemeClr val="accent1"/>
+          </a:lnRef>
+          <a:fillRef idx="3">
+            <a:schemeClr val="accent1"/>
+          </a:fillRef>
+          <a:effectRef idx="2">
+            <a:schemeClr val="accent1"/>
+          </a:effectRef>
+          <a:fontRef idx="minor">
+            <a:schemeClr val="lt1"/>
+          </a:fontRef>
+        </p:style>
+        <p:txBody>
+          <a:bodyPr rtlCol="0" anchor="ctr"/>
+          <a:lstStyle/>
+          <a:p>
+            <a:pPr algn="ctr"/>
+          </a:p>
+        </p:txBody>
+      </p:sp>
+      <p:sp>
+        <p:nvSpPr>
+          <p:cNvPr id="3" name="Rectangle 2"/>
+          <p:cNvSpPr/>
+          <p:nvPr/>
+        </p:nvSpPr>
+        <p:spPr>
+          <a:xfrm>
+            <a:off x="502920" y="457200"/>
+            <a:ext cx="54864" cy="777240"/>
+          </a:xfrm>
+          <a:prstGeom prst="rect">
+            <a:avLst/>
+          </a:prstGeom>
+          <a:solidFill>
+            <a:srgbClr val="2563EB"/>
+          </a:solidFill>
+          <a:ln>
+            <a:noFill/>
+          </a:ln>
+          <a:effectLst/>
+        </p:spPr>
+        <p:style>
+          <a:lnRef idx="1">
+            <a:schemeClr val="accent1"/>
+          </a:lnRef>
+          <a:fillRef idx="3">
+            <a:schemeClr val="accent1"/>
+          </a:fillRef>
+          <a:effectRef idx="2">
+            <a:schemeClr val="accent1"/>
+          </a:effectRef>
+          <a:fontRef idx="minor">
+            <a:schemeClr val="lt1"/>
+          </a:fontRef>
+        </p:style>
+        <p:txBody>
+          <a:bodyPr rtlCol="0" anchor="ctr"/>
+          <a:lstStyle/>
+          <a:p>
+            <a:pPr algn="ctr"/>
+          </a:p>
+        </p:txBody>
+      </p:sp>
+      <p:sp>
+        <p:nvSpPr>
+          <p:cNvPr id="4" name="TextBox 3"/>
+          <p:cNvSpPr txBox="1"/>
+          <p:nvPr/>
+        </p:nvSpPr>
+        <p:spPr>
+          <a:xfrm>
+            <a:off x="713232" y="438912"/>
+            <a:ext cx="10058400" cy="274320"/>
+          </a:xfrm>
+          <a:prstGeom prst="rect">
+            <a:avLst/>
+          </a:prstGeom>
+          <a:noFill/>
+        </p:spPr>
+        <p:txBody>
+          <a:bodyPr wrap="none" lIns="0" tIns="0" rIns="0" bIns="0">
+            <a:spAutoFit/>
+          </a:bodyPr>
+          <a:lstStyle/>
+          <a:p>
+            <a:pPr algn="l"/>
+            <a:r>
+              <a:rPr sz="1150" b="1">
+                <a:solidFill>
+                  <a:srgbClr val="2563EB"/>
+                </a:solidFill>
+                <a:latin typeface="Segoe UI"/>
+              </a:rPr>
+              <a:t>ANNEXES</a:t>
+            </a:r>
+          </a:p>
+        </p:txBody>
+      </p:sp>
+      <p:sp>
+        <p:nvSpPr>
+          <p:cNvPr id="5" name="TextBox 4"/>
+          <p:cNvSpPr txBox="1"/>
+          <p:nvPr/>
+        </p:nvSpPr>
+        <p:spPr>
+          <a:xfrm>
+            <a:off x="685800" y="694944"/>
+            <a:ext cx="10789920" cy="594360"/>
+          </a:xfrm>
+          <a:prstGeom prst="rect">
+            <a:avLst/>
+          </a:prstGeom>
+          <a:noFill/>
+        </p:spPr>
+        <p:txBody>
+          <a:bodyPr wrap="square" lIns="0" tIns="0" rIns="0" bIns="0">
+            <a:spAutoFit/>
+          </a:bodyPr>
+          <a:lstStyle/>
+          <a:p>
+            <a:pPr algn="l"/>
+            <a:r>
+              <a:rPr sz="2400" b="1">
+                <a:solidFill>
+                  <a:srgbClr val="0F172A"/>
+                </a:solidFill>
+                <a:latin typeface="Segoe UI Semibold"/>
+              </a:rPr>
+              <a:t>Diagramme de classes — vue d'ensemble du domaine métier</a:t>
+            </a:r>
+          </a:p>
+        </p:txBody>
+      </p:sp>
+      <p:sp>
+        <p:nvSpPr>
+          <p:cNvPr id="6" name="TextBox 5"/>
+          <p:cNvSpPr txBox="1"/>
+          <p:nvPr/>
+        </p:nvSpPr>
+        <p:spPr>
+          <a:xfrm>
+            <a:off x="502920" y="6528816"/>
+            <a:ext cx="5486400" cy="274320"/>
+          </a:xfrm>
+          <a:prstGeom prst="rect">
+            <a:avLst/>
+          </a:prstGeom>
+          <a:noFill/>
+        </p:spPr>
+        <p:txBody>
+          <a:bodyPr wrap="none" lIns="0" tIns="0" rIns="0" bIns="0">
+            <a:spAutoFit/>
+          </a:bodyPr>
+          <a:lstStyle/>
+          <a:p>
+            <a:r>
+              <a:rPr sz="900">
+                <a:solidFill>
+                  <a:srgbClr val="64748B"/>
+                </a:solidFill>
+                <a:latin typeface="Segoe UI"/>
+              </a:rPr>
+              <a:t>TIRAHOU — Soutenance de mémoire</a:t>
+            </a:r>
+          </a:p>
+        </p:txBody>
+      </p:sp>
+      <p:sp>
+        <p:nvSpPr>
+          <p:cNvPr id="7" name="TextBox 6"/>
+          <p:cNvSpPr txBox="1"/>
+          <p:nvPr/>
+        </p:nvSpPr>
+        <p:spPr>
+          <a:xfrm>
+            <a:off x="10972800" y="6528816"/>
+            <a:ext cx="731520" cy="274320"/>
+          </a:xfrm>
+          <a:prstGeom prst="rect">
+            <a:avLst/>
+          </a:prstGeom>
+          <a:noFill/>
+        </p:spPr>
+        <p:txBody>
+          <a:bodyPr wrap="none" lIns="0" tIns="0" rIns="0" bIns="0">
+            <a:spAutoFit/>
+          </a:bodyPr>
+          <a:lstStyle/>
+          <a:p>
+            <a:pPr algn="r"/>
+            <a:r>
+              <a:rPr sz="900">
+                <a:solidFill>
+                  <a:srgbClr val="64748B"/>
+                </a:solidFill>
+                <a:latin typeface="Segoe UI"/>
+              </a:rPr>
+              <a:t>27</a:t>
+            </a:r>
+          </a:p>
+        </p:txBody>
+      </p:sp>
+      <p:cxnSp>
+        <p:nvCxnSpPr>
+          <p:cNvPr id="8" name="Connector 7"/>
+          <p:cNvCxnSpPr/>
+          <p:nvPr/>
+        </p:nvCxnSpPr>
+        <p:spPr>
+          <a:xfrm>
+            <a:off x="502920" y="6473952"/>
+            <a:ext cx="11183112" cy="0"/>
+          </a:xfrm>
+          <a:prstGeom prst="line">
+            <a:avLst/>
+          </a:prstGeom>
+          <a:ln w="9525">
+            <a:solidFill>
+              <a:srgbClr val="E2E8F0"/>
+            </a:solidFill>
+          </a:ln>
+        </p:spPr>
+        <p:style>
+          <a:lnRef idx="2">
+            <a:schemeClr val="accent1"/>
+          </a:lnRef>
+          <a:fillRef idx="0">
+            <a:schemeClr val="accent1"/>
+          </a:fillRef>
+          <a:effectRef idx="1">
+            <a:schemeClr val="accent1"/>
+          </a:effectRef>
+          <a:fontRef idx="minor">
+            <a:schemeClr val="tx1"/>
+          </a:fontRef>
+        </p:style>
+      </p:cxnSp>
+      <p:sp>
+        <p:nvSpPr>
+          <p:cNvPr id="9" name="Rounded Rectangle 8"/>
+          <p:cNvSpPr/>
+          <p:nvPr/>
+        </p:nvSpPr>
+        <p:spPr>
+          <a:xfrm>
+            <a:off x="3183466" y="1300000"/>
+            <a:ext cx="5822019" cy="5100000"/>
+          </a:xfrm>
+          <a:prstGeom prst="roundRect">
+            <a:avLst>
+              <a:gd name="adj" fmla="val 4500"/>
+            </a:avLst>
+          </a:prstGeom>
+          <a:solidFill>
+            <a:srgbClr val="FFFFFF"/>
+          </a:solidFill>
+          <a:ln w="12700">
+            <a:solidFill>
+              <a:srgbClr val="E2E8F0"/>
+            </a:solidFill>
+          </a:ln>
+          <a:effectLst/>
+        </p:spPr>
+        <p:style>
+          <a:lnRef idx="1">
+            <a:schemeClr val="accent1"/>
+          </a:lnRef>
+          <a:fillRef idx="3">
+            <a:schemeClr val="accent1"/>
+          </a:fillRef>
+          <a:effectRef idx="2">
+            <a:schemeClr val="accent1"/>
+          </a:effectRef>
+          <a:fontRef idx="minor">
+            <a:schemeClr val="lt1"/>
+          </a:fontRef>
+        </p:style>
+        <p:txBody>
+          <a:bodyPr rtlCol="0" anchor="ctr"/>
+          <a:lstStyle/>
+          <a:p>
+            <a:pPr algn="ctr"/>
+          </a:p>
+        </p:txBody>
+      </p:sp>
+      <p:pic>
+        <p:nvPicPr>
+          <p:cNvPr id="10" name="Picture 9" descr="Diagramme_Global.png"/>
+          <p:cNvPicPr>
+            <a:picLocks noChangeAspect="1"/>
+          </p:cNvPicPr>
+          <p:nvPr/>
+        </p:nvPicPr>
+        <p:blipFill>
+          <a:blip r:embed="rId2"/>
+          <a:stretch>
+            <a:fillRect/>
+          </a:stretch>
+        </p:blipFill>
+        <p:spPr>
+          <a:xfrm>
+            <a:off x="3283466" y="1400000"/>
+            <a:ext cx="5622019" cy="4900000"/>
+          </a:xfrm>
+          <a:prstGeom prst="rect">
+            <a:avLst/>
+          </a:prstGeom>
+        </p:spPr>
+      </p:pic>
+    </p:spTree>
+  </p:cSld>
+  <p:clrMapOvr>
+    <a:masterClrMapping/>
+  </p:clrMapOvr>
+</p:sld>
+</file>
+
+<file path=ppt/slides/slide28.xml><?xml version="1.0" encoding="utf-8"?>
+<p:sld xmlns:a="http://schemas.openxmlformats.org/drawingml/2006/main" xmlns:p="http://schemas.openxmlformats.org/presentationml/2006/main" xmlns:r="http://schemas.openxmlformats.org/officeDocument/2006/relationships">
+  <p:cSld>
+    <p:spTree>
+      <p:nvGrpSpPr>
+        <p:cNvPr id="1" name=""/>
+        <p:cNvGrpSpPr/>
+        <p:nvPr/>
+      </p:nvGrpSpPr>
+      <p:grpSpPr/>
+      <p:sp>
+        <p:nvSpPr>
+          <p:cNvPr id="2" name="Rectangle 1"/>
+          <p:cNvSpPr/>
+          <p:nvPr/>
+        </p:nvSpPr>
+        <p:spPr>
+          <a:xfrm>
+            <a:off x="0" y="0"/>
+            <a:ext cx="12191695" cy="6858000"/>
+          </a:xfrm>
+          <a:prstGeom prst="rect">
+            <a:avLst/>
+          </a:prstGeom>
+          <a:solidFill>
+            <a:srgbClr val="F8FAFC"/>
+          </a:solidFill>
+          <a:ln>
+            <a:noFill/>
+          </a:ln>
+          <a:effectLst/>
+        </p:spPr>
+        <p:style>
+          <a:lnRef idx="1">
+            <a:schemeClr val="accent1"/>
+          </a:lnRef>
+          <a:fillRef idx="3">
+            <a:schemeClr val="accent1"/>
+          </a:fillRef>
+          <a:effectRef idx="2">
+            <a:schemeClr val="accent1"/>
+          </a:effectRef>
+          <a:fontRef idx="minor">
+            <a:schemeClr val="lt1"/>
+          </a:fontRef>
+        </p:style>
+        <p:txBody>
+          <a:bodyPr rtlCol="0" anchor="ctr"/>
+          <a:lstStyle/>
+          <a:p>
+            <a:pPr algn="ctr"/>
+          </a:p>
+        </p:txBody>
+      </p:sp>
+      <p:sp>
+        <p:nvSpPr>
+          <p:cNvPr id="3" name="Rectangle 2"/>
+          <p:cNvSpPr/>
+          <p:nvPr/>
+        </p:nvSpPr>
+        <p:spPr>
+          <a:xfrm>
+            <a:off x="502920" y="457200"/>
+            <a:ext cx="54864" cy="777240"/>
+          </a:xfrm>
+          <a:prstGeom prst="rect">
+            <a:avLst/>
+          </a:prstGeom>
+          <a:solidFill>
+            <a:srgbClr val="2563EB"/>
+          </a:solidFill>
+          <a:ln>
+            <a:noFill/>
+          </a:ln>
+          <a:effectLst/>
+        </p:spPr>
+        <p:style>
+          <a:lnRef idx="1">
+            <a:schemeClr val="accent1"/>
+          </a:lnRef>
+          <a:fillRef idx="3">
+            <a:schemeClr val="accent1"/>
+          </a:fillRef>
+          <a:effectRef idx="2">
+            <a:schemeClr val="accent1"/>
+          </a:effectRef>
+          <a:fontRef idx="minor">
+            <a:schemeClr val="lt1"/>
+          </a:fontRef>
+        </p:style>
+        <p:txBody>
+          <a:bodyPr rtlCol="0" anchor="ctr"/>
+          <a:lstStyle/>
+          <a:p>
+            <a:pPr algn="ctr"/>
+          </a:p>
+        </p:txBody>
+      </p:sp>
+      <p:sp>
+        <p:nvSpPr>
+          <p:cNvPr id="4" name="TextBox 3"/>
+          <p:cNvSpPr txBox="1"/>
+          <p:nvPr/>
+        </p:nvSpPr>
+        <p:spPr>
+          <a:xfrm>
+            <a:off x="713232" y="438912"/>
+            <a:ext cx="10058400" cy="274320"/>
+          </a:xfrm>
+          <a:prstGeom prst="rect">
+            <a:avLst/>
+          </a:prstGeom>
+          <a:noFill/>
+        </p:spPr>
+        <p:txBody>
+          <a:bodyPr wrap="none" lIns="0" tIns="0" rIns="0" bIns="0">
+            <a:spAutoFit/>
+          </a:bodyPr>
+          <a:lstStyle/>
+          <a:p>
+            <a:pPr algn="l"/>
+            <a:r>
+              <a:rPr sz="1150" b="1">
+                <a:solidFill>
+                  <a:srgbClr val="2563EB"/>
+                </a:solidFill>
+                <a:latin typeface="Segoe UI"/>
+              </a:rPr>
+              <a:t>ANNEXES</a:t>
+            </a:r>
+          </a:p>
+        </p:txBody>
+      </p:sp>
+      <p:sp>
+        <p:nvSpPr>
+          <p:cNvPr id="5" name="TextBox 4"/>
+          <p:cNvSpPr txBox="1"/>
+          <p:nvPr/>
+        </p:nvSpPr>
+        <p:spPr>
+          <a:xfrm>
+            <a:off x="685800" y="694944"/>
+            <a:ext cx="10789920" cy="594360"/>
+          </a:xfrm>
+          <a:prstGeom prst="rect">
+            <a:avLst/>
+          </a:prstGeom>
+          <a:noFill/>
+        </p:spPr>
+        <p:txBody>
+          <a:bodyPr wrap="square" lIns="0" tIns="0" rIns="0" bIns="0">
+            <a:spAutoFit/>
+          </a:bodyPr>
+          <a:lstStyle/>
+          <a:p>
+            <a:pPr algn="l"/>
+            <a:r>
+              <a:rPr sz="2400" b="1">
+                <a:solidFill>
+                  <a:srgbClr val="0F172A"/>
+                </a:solidFill>
+                <a:latin typeface="Segoe UI Semibold"/>
+              </a:rPr>
+              <a:t>Identités &amp; sécurité — utilisateurs, rôles, permissions</a:t>
+            </a:r>
+          </a:p>
+        </p:txBody>
+      </p:sp>
+      <p:sp>
+        <p:nvSpPr>
+          <p:cNvPr id="6" name="TextBox 5"/>
+          <p:cNvSpPr txBox="1"/>
+          <p:nvPr/>
+        </p:nvSpPr>
+        <p:spPr>
+          <a:xfrm>
+            <a:off x="502920" y="6528816"/>
+            <a:ext cx="5486400" cy="274320"/>
+          </a:xfrm>
+          <a:prstGeom prst="rect">
+            <a:avLst/>
+          </a:prstGeom>
+          <a:noFill/>
+        </p:spPr>
+        <p:txBody>
+          <a:bodyPr wrap="none" lIns="0" tIns="0" rIns="0" bIns="0">
+            <a:spAutoFit/>
+          </a:bodyPr>
+          <a:lstStyle/>
+          <a:p>
+            <a:r>
+              <a:rPr sz="900">
+                <a:solidFill>
+                  <a:srgbClr val="64748B"/>
+                </a:solidFill>
+                <a:latin typeface="Segoe UI"/>
+              </a:rPr>
+              <a:t>TIRAHOU — Soutenance de mémoire</a:t>
+            </a:r>
+          </a:p>
+        </p:txBody>
+      </p:sp>
+      <p:sp>
+        <p:nvSpPr>
+          <p:cNvPr id="7" name="TextBox 6"/>
+          <p:cNvSpPr txBox="1"/>
+          <p:nvPr/>
+        </p:nvSpPr>
+        <p:spPr>
+          <a:xfrm>
+            <a:off x="10972800" y="6528816"/>
+            <a:ext cx="731520" cy="274320"/>
+          </a:xfrm>
+          <a:prstGeom prst="rect">
+            <a:avLst/>
+          </a:prstGeom>
+          <a:noFill/>
+        </p:spPr>
+        <p:txBody>
+          <a:bodyPr wrap="none" lIns="0" tIns="0" rIns="0" bIns="0">
+            <a:spAutoFit/>
+          </a:bodyPr>
+          <a:lstStyle/>
+          <a:p>
+            <a:pPr algn="r"/>
+            <a:r>
+              <a:rPr sz="900">
+                <a:solidFill>
+                  <a:srgbClr val="64748B"/>
+                </a:solidFill>
+                <a:latin typeface="Segoe UI"/>
+              </a:rPr>
+              <a:t>28</a:t>
+            </a:r>
+          </a:p>
+        </p:txBody>
+      </p:sp>
+      <p:cxnSp>
+        <p:nvCxnSpPr>
+          <p:cNvPr id="8" name="Connector 7"/>
+          <p:cNvCxnSpPr/>
+          <p:nvPr/>
+        </p:nvCxnSpPr>
+        <p:spPr>
+          <a:xfrm>
+            <a:off x="502920" y="6473952"/>
+            <a:ext cx="11183112" cy="0"/>
+          </a:xfrm>
+          <a:prstGeom prst="line">
+            <a:avLst/>
+          </a:prstGeom>
+          <a:ln w="9525">
+            <a:solidFill>
+              <a:srgbClr val="E2E8F0"/>
+            </a:solidFill>
+          </a:ln>
+        </p:spPr>
+        <p:style>
+          <a:lnRef idx="2">
+            <a:schemeClr val="accent1"/>
+          </a:lnRef>
+          <a:fillRef idx="0">
+            <a:schemeClr val="accent1"/>
+          </a:fillRef>
+          <a:effectRef idx="1">
+            <a:schemeClr val="accent1"/>
+          </a:effectRef>
+          <a:fontRef idx="minor">
+            <a:schemeClr val="tx1"/>
+          </a:fontRef>
+        </p:style>
+      </p:cxnSp>
+      <p:sp>
+        <p:nvSpPr>
+          <p:cNvPr id="9" name="Rounded Rectangle 8"/>
+          <p:cNvSpPr/>
+          <p:nvPr/>
+        </p:nvSpPr>
+        <p:spPr>
+          <a:xfrm>
+            <a:off x="2360096" y="1500000"/>
+            <a:ext cx="7468760" cy="4300000"/>
+          </a:xfrm>
+          <a:prstGeom prst="roundRect">
+            <a:avLst>
+              <a:gd name="adj" fmla="val 4500"/>
+            </a:avLst>
+          </a:prstGeom>
+          <a:solidFill>
+            <a:srgbClr val="FFFFFF"/>
+          </a:solidFill>
+          <a:ln w="12700">
+            <a:solidFill>
+              <a:srgbClr val="E2E8F0"/>
+            </a:solidFill>
+          </a:ln>
+          <a:effectLst/>
+        </p:spPr>
+        <p:style>
+          <a:lnRef idx="1">
+            <a:schemeClr val="accent1"/>
+          </a:lnRef>
+          <a:fillRef idx="3">
+            <a:schemeClr val="accent1"/>
+          </a:fillRef>
+          <a:effectRef idx="2">
+            <a:schemeClr val="accent1"/>
+          </a:effectRef>
+          <a:fontRef idx="minor">
+            <a:schemeClr val="lt1"/>
+          </a:fontRef>
+        </p:style>
+        <p:txBody>
+          <a:bodyPr rtlCol="0" anchor="ctr"/>
+          <a:lstStyle/>
+          <a:p>
+            <a:pPr algn="ctr"/>
+          </a:p>
+        </p:txBody>
+      </p:sp>
+      <p:pic>
+        <p:nvPicPr>
+          <p:cNvPr id="10" name="Picture 9" descr="03_Identites.png"/>
+          <p:cNvPicPr>
+            <a:picLocks noChangeAspect="1"/>
+          </p:cNvPicPr>
+          <p:nvPr/>
+        </p:nvPicPr>
+        <p:blipFill>
+          <a:blip r:embed="rId2"/>
+          <a:stretch>
+            <a:fillRect/>
+          </a:stretch>
+        </p:blipFill>
+        <p:spPr>
+          <a:xfrm>
+            <a:off x="2588696" y="1728600"/>
+            <a:ext cx="7011560" cy="3842800"/>
+          </a:xfrm>
+          <a:prstGeom prst="rect">
+            <a:avLst/>
+          </a:prstGeom>
+        </p:spPr>
+      </p:pic>
+      <p:sp>
+        <p:nvSpPr>
+          <p:cNvPr id="11" name="TextBox 10"/>
+          <p:cNvSpPr txBox="1"/>
+          <p:nvPr/>
+        </p:nvSpPr>
+        <p:spPr>
+          <a:xfrm>
+            <a:off x="502920" y="5950000"/>
+            <a:ext cx="11183112" cy="320000"/>
+          </a:xfrm>
+          <a:prstGeom prst="rect">
+            <a:avLst/>
+          </a:prstGeom>
+          <a:noFill/>
+        </p:spPr>
+        <p:txBody>
+          <a:bodyPr wrap="none" lIns="0" tIns="0" rIns="0" bIns="0">
+            <a:spAutoFit/>
+          </a:bodyPr>
+          <a:lstStyle/>
+          <a:p>
+            <a:pPr algn="ctr"/>
+            <a:r>
+              <a:rPr sz="1100" i="1">
+                <a:solidFill>
+                  <a:srgbClr val="64748B"/>
+                </a:solidFill>
+                <a:latin typeface="Segoe UI"/>
+              </a:rPr>
+              <a:t>Base du contrôle d'accès RBAC : Utilisateur, Compte, Role, Permission, SessionConnexion, JournalAudit.</a:t>
+            </a:r>
+          </a:p>
+        </p:txBody>
+      </p:sp>
+    </p:spTree>
+  </p:cSld>
+  <p:clrMapOvr>
+    <a:masterClrMapping/>
+  </p:clrMapOvr>
+</p:sld>
+</file>
+
+<file path=ppt/slides/slide29.xml><?xml version="1.0" encoding="utf-8"?>
+<p:sld xmlns:a="http://schemas.openxmlformats.org/drawingml/2006/main" xmlns:p="http://schemas.openxmlformats.org/presentationml/2006/main" xmlns:r="http://schemas.openxmlformats.org/officeDocument/2006/relationships">
+  <p:cSld>
+    <p:spTree>
+      <p:nvGrpSpPr>
+        <p:cNvPr id="1" name=""/>
+        <p:cNvGrpSpPr/>
+        <p:nvPr/>
+      </p:nvGrpSpPr>
+      <p:grpSpPr/>
+      <p:sp>
+        <p:nvSpPr>
+          <p:cNvPr id="2" name="Rectangle 1"/>
+          <p:cNvSpPr/>
+          <p:nvPr/>
+        </p:nvSpPr>
+        <p:spPr>
+          <a:xfrm>
+            <a:off x="0" y="0"/>
+            <a:ext cx="12191695" cy="6858000"/>
+          </a:xfrm>
+          <a:prstGeom prst="rect">
+            <a:avLst/>
+          </a:prstGeom>
+          <a:solidFill>
+            <a:srgbClr val="F8FAFC"/>
+          </a:solidFill>
+          <a:ln>
+            <a:noFill/>
+          </a:ln>
+          <a:effectLst/>
+        </p:spPr>
+        <p:style>
+          <a:lnRef idx="1">
+            <a:schemeClr val="accent1"/>
+          </a:lnRef>
+          <a:fillRef idx="3">
+            <a:schemeClr val="accent1"/>
+          </a:fillRef>
+          <a:effectRef idx="2">
+            <a:schemeClr val="accent1"/>
+          </a:effectRef>
+          <a:fontRef idx="minor">
+            <a:schemeClr val="lt1"/>
+          </a:fontRef>
+        </p:style>
+        <p:txBody>
+          <a:bodyPr rtlCol="0" anchor="ctr"/>
+          <a:lstStyle/>
+          <a:p>
+            <a:pPr algn="ctr"/>
+          </a:p>
+        </p:txBody>
+      </p:sp>
+      <p:sp>
+        <p:nvSpPr>
+          <p:cNvPr id="3" name="Rectangle 2"/>
+          <p:cNvSpPr/>
+          <p:nvPr/>
+        </p:nvSpPr>
+        <p:spPr>
+          <a:xfrm>
+            <a:off x="502920" y="457200"/>
+            <a:ext cx="54864" cy="777240"/>
+          </a:xfrm>
+          <a:prstGeom prst="rect">
+            <a:avLst/>
+          </a:prstGeom>
+          <a:solidFill>
+            <a:srgbClr val="2563EB"/>
+          </a:solidFill>
+          <a:ln>
+            <a:noFill/>
+          </a:ln>
+          <a:effectLst/>
+        </p:spPr>
+        <p:style>
+          <a:lnRef idx="1">
+            <a:schemeClr val="accent1"/>
+          </a:lnRef>
+          <a:fillRef idx="3">
+            <a:schemeClr val="accent1"/>
+          </a:fillRef>
+          <a:effectRef idx="2">
+            <a:schemeClr val="accent1"/>
+          </a:effectRef>
+          <a:fontRef idx="minor">
+            <a:schemeClr val="lt1"/>
+          </a:fontRef>
+        </p:style>
+        <p:txBody>
+          <a:bodyPr rtlCol="0" anchor="ctr"/>
+          <a:lstStyle/>
+          <a:p>
+            <a:pPr algn="ctr"/>
+          </a:p>
+        </p:txBody>
+      </p:sp>
+      <p:sp>
+        <p:nvSpPr>
+          <p:cNvPr id="4" name="TextBox 3"/>
+          <p:cNvSpPr txBox="1"/>
+          <p:nvPr/>
+        </p:nvSpPr>
+        <p:spPr>
+          <a:xfrm>
+            <a:off x="713232" y="438912"/>
+            <a:ext cx="10058400" cy="274320"/>
+          </a:xfrm>
+          <a:prstGeom prst="rect">
+            <a:avLst/>
+          </a:prstGeom>
+          <a:noFill/>
+        </p:spPr>
+        <p:txBody>
+          <a:bodyPr wrap="none" lIns="0" tIns="0" rIns="0" bIns="0">
+            <a:spAutoFit/>
+          </a:bodyPr>
+          <a:lstStyle/>
+          <a:p>
+            <a:pPr algn="l"/>
+            <a:r>
+              <a:rPr sz="1150" b="1">
+                <a:solidFill>
+                  <a:srgbClr val="2563EB"/>
+                </a:solidFill>
+                <a:latin typeface="Segoe UI"/>
+              </a:rPr>
+              <a:t>ANNEXES</a:t>
+            </a:r>
+          </a:p>
+        </p:txBody>
+      </p:sp>
+      <p:sp>
+        <p:nvSpPr>
+          <p:cNvPr id="5" name="TextBox 4"/>
+          <p:cNvSpPr txBox="1"/>
+          <p:nvPr/>
+        </p:nvSpPr>
+        <p:spPr>
+          <a:xfrm>
+            <a:off x="685800" y="694944"/>
+            <a:ext cx="10789920" cy="594360"/>
+          </a:xfrm>
+          <a:prstGeom prst="rect">
+            <a:avLst/>
+          </a:prstGeom>
+          <a:noFill/>
+        </p:spPr>
+        <p:txBody>
+          <a:bodyPr wrap="square" lIns="0" tIns="0" rIns="0" bIns="0">
+            <a:spAutoFit/>
+          </a:bodyPr>
+          <a:lstStyle/>
+          <a:p>
+            <a:pPr algn="l"/>
+            <a:r>
+              <a:rPr sz="2400" b="1">
+                <a:solidFill>
+                  <a:srgbClr val="0F172A"/>
+                </a:solidFill>
+                <a:latin typeface="Segoe UI Semibold"/>
+              </a:rPr>
+              <a:t>Structure LMD — niveaux, semestres, UE, EC, crédits</a:t>
+            </a:r>
+          </a:p>
+        </p:txBody>
+      </p:sp>
+      <p:sp>
+        <p:nvSpPr>
+          <p:cNvPr id="6" name="TextBox 5"/>
+          <p:cNvSpPr txBox="1"/>
+          <p:nvPr/>
+        </p:nvSpPr>
+        <p:spPr>
+          <a:xfrm>
+            <a:off x="502920" y="6528816"/>
+            <a:ext cx="5486400" cy="274320"/>
+          </a:xfrm>
+          <a:prstGeom prst="rect">
+            <a:avLst/>
+          </a:prstGeom>
+          <a:noFill/>
+        </p:spPr>
+        <p:txBody>
+          <a:bodyPr wrap="none" lIns="0" tIns="0" rIns="0" bIns="0">
+            <a:spAutoFit/>
+          </a:bodyPr>
+          <a:lstStyle/>
+          <a:p>
+            <a:r>
+              <a:rPr sz="900">
+                <a:solidFill>
+                  <a:srgbClr val="64748B"/>
+                </a:solidFill>
+                <a:latin typeface="Segoe UI"/>
+              </a:rPr>
+              <a:t>TIRAHOU — Soutenance de mémoire</a:t>
+            </a:r>
+          </a:p>
+        </p:txBody>
+      </p:sp>
+      <p:sp>
+        <p:nvSpPr>
+          <p:cNvPr id="7" name="TextBox 6"/>
+          <p:cNvSpPr txBox="1"/>
+          <p:nvPr/>
+        </p:nvSpPr>
+        <p:spPr>
+          <a:xfrm>
+            <a:off x="10972800" y="6528816"/>
+            <a:ext cx="731520" cy="274320"/>
+          </a:xfrm>
+          <a:prstGeom prst="rect">
+            <a:avLst/>
+          </a:prstGeom>
+          <a:noFill/>
+        </p:spPr>
+        <p:txBody>
+          <a:bodyPr wrap="none" lIns="0" tIns="0" rIns="0" bIns="0">
+            <a:spAutoFit/>
+          </a:bodyPr>
+          <a:lstStyle/>
+          <a:p>
+            <a:pPr algn="r"/>
+            <a:r>
+              <a:rPr sz="900">
+                <a:solidFill>
+                  <a:srgbClr val="64748B"/>
+                </a:solidFill>
+                <a:latin typeface="Segoe UI"/>
+              </a:rPr>
+              <a:t>29</a:t>
+            </a:r>
+          </a:p>
+        </p:txBody>
+      </p:sp>
+      <p:cxnSp>
+        <p:nvCxnSpPr>
+          <p:cNvPr id="8" name="Connector 7"/>
+          <p:cNvCxnSpPr/>
+          <p:nvPr/>
+        </p:nvCxnSpPr>
+        <p:spPr>
+          <a:xfrm>
+            <a:off x="502920" y="6473952"/>
+            <a:ext cx="11183112" cy="0"/>
+          </a:xfrm>
+          <a:prstGeom prst="line">
+            <a:avLst/>
+          </a:prstGeom>
+          <a:ln w="9525">
+            <a:solidFill>
+              <a:srgbClr val="E2E8F0"/>
+            </a:solidFill>
+          </a:ln>
+        </p:spPr>
+        <p:style>
+          <a:lnRef idx="2">
+            <a:schemeClr val="accent1"/>
+          </a:lnRef>
+          <a:fillRef idx="0">
+            <a:schemeClr val="accent1"/>
+          </a:fillRef>
+          <a:effectRef idx="1">
+            <a:schemeClr val="accent1"/>
+          </a:effectRef>
+          <a:fontRef idx="minor">
+            <a:schemeClr val="tx1"/>
+          </a:fontRef>
+        </p:style>
+      </p:cxnSp>
+      <p:sp>
+        <p:nvSpPr>
+          <p:cNvPr id="9" name="Rounded Rectangle 8"/>
+          <p:cNvSpPr/>
+          <p:nvPr/>
+        </p:nvSpPr>
+        <p:spPr>
+          <a:xfrm>
+            <a:off x="4676135" y="1500000"/>
+            <a:ext cx="2836682" cy="4300000"/>
+          </a:xfrm>
+          <a:prstGeom prst="roundRect">
+            <a:avLst>
+              <a:gd name="adj" fmla="val 4500"/>
+            </a:avLst>
+          </a:prstGeom>
+          <a:solidFill>
+            <a:srgbClr val="FFFFFF"/>
+          </a:solidFill>
+          <a:ln w="12700">
+            <a:solidFill>
+              <a:srgbClr val="E2E8F0"/>
+            </a:solidFill>
+          </a:ln>
+          <a:effectLst/>
+        </p:spPr>
+        <p:style>
+          <a:lnRef idx="1">
+            <a:schemeClr val="accent1"/>
+          </a:lnRef>
+          <a:fillRef idx="3">
+            <a:schemeClr val="accent1"/>
+          </a:fillRef>
+          <a:effectRef idx="2">
+            <a:schemeClr val="accent1"/>
+          </a:effectRef>
+          <a:fontRef idx="minor">
+            <a:schemeClr val="lt1"/>
+          </a:fontRef>
+        </p:style>
+        <p:txBody>
+          <a:bodyPr rtlCol="0" anchor="ctr"/>
+          <a:lstStyle/>
+          <a:p>
+            <a:pPr algn="ctr"/>
+          </a:p>
+        </p:txBody>
+      </p:sp>
+      <p:pic>
+        <p:nvPicPr>
+          <p:cNvPr id="10" name="Picture 9" descr="08_LMD.png"/>
+          <p:cNvPicPr>
+            <a:picLocks noChangeAspect="1"/>
+          </p:cNvPicPr>
+          <p:nvPr/>
+        </p:nvPicPr>
+        <p:blipFill>
+          <a:blip r:embed="rId2"/>
+          <a:stretch>
+            <a:fillRect/>
+          </a:stretch>
+        </p:blipFill>
+        <p:spPr>
+          <a:xfrm>
+            <a:off x="4904735" y="1728600"/>
+            <a:ext cx="2379482" cy="3842800"/>
+          </a:xfrm>
+          <a:prstGeom prst="rect">
+            <a:avLst/>
+          </a:prstGeom>
+        </p:spPr>
+      </p:pic>
+      <p:sp>
+        <p:nvSpPr>
+          <p:cNvPr id="11" name="TextBox 10"/>
+          <p:cNvSpPr txBox="1"/>
+          <p:nvPr/>
+        </p:nvSpPr>
+        <p:spPr>
+          <a:xfrm>
+            <a:off x="502920" y="5950000"/>
+            <a:ext cx="11183112" cy="320000"/>
+          </a:xfrm>
+          <a:prstGeom prst="rect">
+            <a:avLst/>
+          </a:prstGeom>
+          <a:noFill/>
+        </p:spPr>
+        <p:txBody>
+          <a:bodyPr wrap="none" lIns="0" tIns="0" rIns="0" bIns="0">
+            <a:spAutoFit/>
+          </a:bodyPr>
+          <a:lstStyle/>
+          <a:p>
+            <a:pPr algn="ctr"/>
+            <a:r>
+              <a:rPr sz="1100" i="1">
+                <a:solidFill>
+                  <a:srgbClr val="64748B"/>
+                </a:solidFill>
+                <a:latin typeface="Segoe UI"/>
+              </a:rPr>
+              <a:t>Modélisation générique du système LMD, réutilisable pour tout programme Licence ou Master.</a:t>
+            </a:r>
+          </a:p>
+        </p:txBody>
+      </p:sp>
+    </p:spTree>
+  </p:cSld>
+  <p:clrMapOvr>
+    <a:masterClrMapping/>
+  </p:clrMapOvr>
+</p:sld>
+</file>
+
 <file path=ppt/slides/slide3.xml><?xml version="1.0" encoding="utf-8"?>
 <p:sld xmlns:a="http://schemas.openxmlformats.org/drawingml/2006/main" xmlns:p="http://schemas.openxmlformats.org/presentationml/2006/main" xmlns:r="http://schemas.openxmlformats.org/officeDocument/2006/relationships">
   <p:cSld>
@@ -22311,6 +23834,780 @@
                 <a:latin typeface="Segoe UI"/>
               </a:rPr>
               <a:t>Communication étudiants quasi exclusivement papier</a:t>
+            </a:r>
+          </a:p>
+        </p:txBody>
+      </p:sp>
+    </p:spTree>
+  </p:cSld>
+  <p:clrMapOvr>
+    <a:masterClrMapping/>
+  </p:clrMapOvr>
+</p:sld>
+</file>
+
+<file path=ppt/slides/slide30.xml><?xml version="1.0" encoding="utf-8"?>
+<p:sld xmlns:a="http://schemas.openxmlformats.org/drawingml/2006/main" xmlns:p="http://schemas.openxmlformats.org/presentationml/2006/main" xmlns:r="http://schemas.openxmlformats.org/officeDocument/2006/relationships">
+  <p:cSld>
+    <p:spTree>
+      <p:nvGrpSpPr>
+        <p:cNvPr id="1" name=""/>
+        <p:cNvGrpSpPr/>
+        <p:nvPr/>
+      </p:nvGrpSpPr>
+      <p:grpSpPr/>
+      <p:sp>
+        <p:nvSpPr>
+          <p:cNvPr id="2" name="Rectangle 1"/>
+          <p:cNvSpPr/>
+          <p:nvPr/>
+        </p:nvSpPr>
+        <p:spPr>
+          <a:xfrm>
+            <a:off x="0" y="0"/>
+            <a:ext cx="12191695" cy="6858000"/>
+          </a:xfrm>
+          <a:prstGeom prst="rect">
+            <a:avLst/>
+          </a:prstGeom>
+          <a:solidFill>
+            <a:srgbClr val="F8FAFC"/>
+          </a:solidFill>
+          <a:ln>
+            <a:noFill/>
+          </a:ln>
+          <a:effectLst/>
+        </p:spPr>
+        <p:style>
+          <a:lnRef idx="1">
+            <a:schemeClr val="accent1"/>
+          </a:lnRef>
+          <a:fillRef idx="3">
+            <a:schemeClr val="accent1"/>
+          </a:fillRef>
+          <a:effectRef idx="2">
+            <a:schemeClr val="accent1"/>
+          </a:effectRef>
+          <a:fontRef idx="minor">
+            <a:schemeClr val="lt1"/>
+          </a:fontRef>
+        </p:style>
+        <p:txBody>
+          <a:bodyPr rtlCol="0" anchor="ctr"/>
+          <a:lstStyle/>
+          <a:p>
+            <a:pPr algn="ctr"/>
+          </a:p>
+        </p:txBody>
+      </p:sp>
+      <p:sp>
+        <p:nvSpPr>
+          <p:cNvPr id="3" name="Rectangle 2"/>
+          <p:cNvSpPr/>
+          <p:nvPr/>
+        </p:nvSpPr>
+        <p:spPr>
+          <a:xfrm>
+            <a:off x="502920" y="457200"/>
+            <a:ext cx="54864" cy="777240"/>
+          </a:xfrm>
+          <a:prstGeom prst="rect">
+            <a:avLst/>
+          </a:prstGeom>
+          <a:solidFill>
+            <a:srgbClr val="2563EB"/>
+          </a:solidFill>
+          <a:ln>
+            <a:noFill/>
+          </a:ln>
+          <a:effectLst/>
+        </p:spPr>
+        <p:style>
+          <a:lnRef idx="1">
+            <a:schemeClr val="accent1"/>
+          </a:lnRef>
+          <a:fillRef idx="3">
+            <a:schemeClr val="accent1"/>
+          </a:fillRef>
+          <a:effectRef idx="2">
+            <a:schemeClr val="accent1"/>
+          </a:effectRef>
+          <a:fontRef idx="minor">
+            <a:schemeClr val="lt1"/>
+          </a:fontRef>
+        </p:style>
+        <p:txBody>
+          <a:bodyPr rtlCol="0" anchor="ctr"/>
+          <a:lstStyle/>
+          <a:p>
+            <a:pPr algn="ctr"/>
+          </a:p>
+        </p:txBody>
+      </p:sp>
+      <p:sp>
+        <p:nvSpPr>
+          <p:cNvPr id="4" name="TextBox 3"/>
+          <p:cNvSpPr txBox="1"/>
+          <p:nvPr/>
+        </p:nvSpPr>
+        <p:spPr>
+          <a:xfrm>
+            <a:off x="713232" y="438912"/>
+            <a:ext cx="10058400" cy="274320"/>
+          </a:xfrm>
+          <a:prstGeom prst="rect">
+            <a:avLst/>
+          </a:prstGeom>
+          <a:noFill/>
+        </p:spPr>
+        <p:txBody>
+          <a:bodyPr wrap="none" lIns="0" tIns="0" rIns="0" bIns="0">
+            <a:spAutoFit/>
+          </a:bodyPr>
+          <a:lstStyle/>
+          <a:p>
+            <a:pPr algn="l"/>
+            <a:r>
+              <a:rPr sz="1150" b="1">
+                <a:solidFill>
+                  <a:srgbClr val="2563EB"/>
+                </a:solidFill>
+                <a:latin typeface="Segoe UI"/>
+              </a:rPr>
+              <a:t>ANNEXES</a:t>
+            </a:r>
+          </a:p>
+        </p:txBody>
+      </p:sp>
+      <p:sp>
+        <p:nvSpPr>
+          <p:cNvPr id="5" name="TextBox 4"/>
+          <p:cNvSpPr txBox="1"/>
+          <p:nvPr/>
+        </p:nvSpPr>
+        <p:spPr>
+          <a:xfrm>
+            <a:off x="685800" y="694944"/>
+            <a:ext cx="10789920" cy="594360"/>
+          </a:xfrm>
+          <a:prstGeom prst="rect">
+            <a:avLst/>
+          </a:prstGeom>
+          <a:noFill/>
+        </p:spPr>
+        <p:txBody>
+          <a:bodyPr wrap="square" lIns="0" tIns="0" rIns="0" bIns="0">
+            <a:spAutoFit/>
+          </a:bodyPr>
+          <a:lstStyle/>
+          <a:p>
+            <a:pPr algn="l"/>
+            <a:r>
+              <a:rPr sz="2400" b="1">
+                <a:solidFill>
+                  <a:srgbClr val="0F172A"/>
+                </a:solidFill>
+                <a:latin typeface="Segoe UI Semibold"/>
+              </a:rPr>
+              <a:t>Évaluations — modèle polymorphe</a:t>
+            </a:r>
+          </a:p>
+        </p:txBody>
+      </p:sp>
+      <p:sp>
+        <p:nvSpPr>
+          <p:cNvPr id="6" name="TextBox 5"/>
+          <p:cNvSpPr txBox="1"/>
+          <p:nvPr/>
+        </p:nvSpPr>
+        <p:spPr>
+          <a:xfrm>
+            <a:off x="502920" y="6528816"/>
+            <a:ext cx="5486400" cy="274320"/>
+          </a:xfrm>
+          <a:prstGeom prst="rect">
+            <a:avLst/>
+          </a:prstGeom>
+          <a:noFill/>
+        </p:spPr>
+        <p:txBody>
+          <a:bodyPr wrap="none" lIns="0" tIns="0" rIns="0" bIns="0">
+            <a:spAutoFit/>
+          </a:bodyPr>
+          <a:lstStyle/>
+          <a:p>
+            <a:r>
+              <a:rPr sz="900">
+                <a:solidFill>
+                  <a:srgbClr val="64748B"/>
+                </a:solidFill>
+                <a:latin typeface="Segoe UI"/>
+              </a:rPr>
+              <a:t>TIRAHOU — Soutenance de mémoire</a:t>
+            </a:r>
+          </a:p>
+        </p:txBody>
+      </p:sp>
+      <p:sp>
+        <p:nvSpPr>
+          <p:cNvPr id="7" name="TextBox 6"/>
+          <p:cNvSpPr txBox="1"/>
+          <p:nvPr/>
+        </p:nvSpPr>
+        <p:spPr>
+          <a:xfrm>
+            <a:off x="10972800" y="6528816"/>
+            <a:ext cx="731520" cy="274320"/>
+          </a:xfrm>
+          <a:prstGeom prst="rect">
+            <a:avLst/>
+          </a:prstGeom>
+          <a:noFill/>
+        </p:spPr>
+        <p:txBody>
+          <a:bodyPr wrap="none" lIns="0" tIns="0" rIns="0" bIns="0">
+            <a:spAutoFit/>
+          </a:bodyPr>
+          <a:lstStyle/>
+          <a:p>
+            <a:pPr algn="r"/>
+            <a:r>
+              <a:rPr sz="900">
+                <a:solidFill>
+                  <a:srgbClr val="64748B"/>
+                </a:solidFill>
+                <a:latin typeface="Segoe UI"/>
+              </a:rPr>
+              <a:t>30</a:t>
+            </a:r>
+          </a:p>
+        </p:txBody>
+      </p:sp>
+      <p:cxnSp>
+        <p:nvCxnSpPr>
+          <p:cNvPr id="8" name="Connector 7"/>
+          <p:cNvCxnSpPr/>
+          <p:nvPr/>
+        </p:nvCxnSpPr>
+        <p:spPr>
+          <a:xfrm>
+            <a:off x="502920" y="6473952"/>
+            <a:ext cx="11183112" cy="0"/>
+          </a:xfrm>
+          <a:prstGeom prst="line">
+            <a:avLst/>
+          </a:prstGeom>
+          <a:ln w="9525">
+            <a:solidFill>
+              <a:srgbClr val="E2E8F0"/>
+            </a:solidFill>
+          </a:ln>
+        </p:spPr>
+        <p:style>
+          <a:lnRef idx="2">
+            <a:schemeClr val="accent1"/>
+          </a:lnRef>
+          <a:fillRef idx="0">
+            <a:schemeClr val="accent1"/>
+          </a:fillRef>
+          <a:effectRef idx="1">
+            <a:schemeClr val="accent1"/>
+          </a:effectRef>
+          <a:fontRef idx="minor">
+            <a:schemeClr val="tx1"/>
+          </a:fontRef>
+        </p:style>
+      </p:cxnSp>
+      <p:sp>
+        <p:nvSpPr>
+          <p:cNvPr id="9" name="Rounded Rectangle 8"/>
+          <p:cNvSpPr/>
+          <p:nvPr/>
+        </p:nvSpPr>
+        <p:spPr>
+          <a:xfrm>
+            <a:off x="3516278" y="1500000"/>
+            <a:ext cx="5156395" cy="4300000"/>
+          </a:xfrm>
+          <a:prstGeom prst="roundRect">
+            <a:avLst>
+              <a:gd name="adj" fmla="val 4500"/>
+            </a:avLst>
+          </a:prstGeom>
+          <a:solidFill>
+            <a:srgbClr val="FFFFFF"/>
+          </a:solidFill>
+          <a:ln w="12700">
+            <a:solidFill>
+              <a:srgbClr val="E2E8F0"/>
+            </a:solidFill>
+          </a:ln>
+          <a:effectLst/>
+        </p:spPr>
+        <p:style>
+          <a:lnRef idx="1">
+            <a:schemeClr val="accent1"/>
+          </a:lnRef>
+          <a:fillRef idx="3">
+            <a:schemeClr val="accent1"/>
+          </a:fillRef>
+          <a:effectRef idx="2">
+            <a:schemeClr val="accent1"/>
+          </a:effectRef>
+          <a:fontRef idx="minor">
+            <a:schemeClr val="lt1"/>
+          </a:fontRef>
+        </p:style>
+        <p:txBody>
+          <a:bodyPr rtlCol="0" anchor="ctr"/>
+          <a:lstStyle/>
+          <a:p>
+            <a:pPr algn="ctr"/>
+          </a:p>
+        </p:txBody>
+      </p:sp>
+      <p:pic>
+        <p:nvPicPr>
+          <p:cNvPr id="10" name="Picture 9" descr="17_Evaluations.png"/>
+          <p:cNvPicPr>
+            <a:picLocks noChangeAspect="1"/>
+          </p:cNvPicPr>
+          <p:nvPr/>
+        </p:nvPicPr>
+        <p:blipFill>
+          <a:blip r:embed="rId2"/>
+          <a:stretch>
+            <a:fillRect/>
+          </a:stretch>
+        </p:blipFill>
+        <p:spPr>
+          <a:xfrm>
+            <a:off x="3744878" y="1728600"/>
+            <a:ext cx="4699195" cy="3842800"/>
+          </a:xfrm>
+          <a:prstGeom prst="rect">
+            <a:avLst/>
+          </a:prstGeom>
+        </p:spPr>
+      </p:pic>
+      <p:sp>
+        <p:nvSpPr>
+          <p:cNvPr id="11" name="TextBox 10"/>
+          <p:cNvSpPr txBox="1"/>
+          <p:nvPr/>
+        </p:nvSpPr>
+        <p:spPr>
+          <a:xfrm>
+            <a:off x="502920" y="5950000"/>
+            <a:ext cx="11183112" cy="320000"/>
+          </a:xfrm>
+          <a:prstGeom prst="rect">
+            <a:avLst/>
+          </a:prstGeom>
+          <a:noFill/>
+        </p:spPr>
+        <p:txBody>
+          <a:bodyPr wrap="none" lIns="0" tIns="0" rIns="0" bIns="0">
+            <a:spAutoFit/>
+          </a:bodyPr>
+          <a:lstStyle/>
+          <a:p>
+            <a:pPr algn="ctr"/>
+            <a:r>
+              <a:rPr sz="1100" i="1">
+                <a:solidFill>
+                  <a:srgbClr val="64748B"/>
+                </a:solidFill>
+                <a:latin typeface="Segoe UI"/>
+              </a:rPr>
+              <a:t>Une évaluation abstraite spécialisée en Examen, Quiz, Devoir ou Projet — extensible sans casser l'existant.</a:t>
+            </a:r>
+          </a:p>
+        </p:txBody>
+      </p:sp>
+    </p:spTree>
+  </p:cSld>
+  <p:clrMapOvr>
+    <a:masterClrMapping/>
+  </p:clrMapOvr>
+</p:sld>
+</file>
+
+<file path=ppt/slides/slide31.xml><?xml version="1.0" encoding="utf-8"?>
+<p:sld xmlns:a="http://schemas.openxmlformats.org/drawingml/2006/main" xmlns:p="http://schemas.openxmlformats.org/presentationml/2006/main" xmlns:r="http://schemas.openxmlformats.org/officeDocument/2006/relationships">
+  <p:cSld>
+    <p:spTree>
+      <p:nvGrpSpPr>
+        <p:cNvPr id="1" name=""/>
+        <p:cNvGrpSpPr/>
+        <p:nvPr/>
+      </p:nvGrpSpPr>
+      <p:grpSpPr/>
+      <p:sp>
+        <p:nvSpPr>
+          <p:cNvPr id="2" name="Rectangle 1"/>
+          <p:cNvSpPr/>
+          <p:nvPr/>
+        </p:nvSpPr>
+        <p:spPr>
+          <a:xfrm>
+            <a:off x="0" y="0"/>
+            <a:ext cx="12191695" cy="6858000"/>
+          </a:xfrm>
+          <a:prstGeom prst="rect">
+            <a:avLst/>
+          </a:prstGeom>
+          <a:solidFill>
+            <a:srgbClr val="F8FAFC"/>
+          </a:solidFill>
+          <a:ln>
+            <a:noFill/>
+          </a:ln>
+          <a:effectLst/>
+        </p:spPr>
+        <p:style>
+          <a:lnRef idx="1">
+            <a:schemeClr val="accent1"/>
+          </a:lnRef>
+          <a:fillRef idx="3">
+            <a:schemeClr val="accent1"/>
+          </a:fillRef>
+          <a:effectRef idx="2">
+            <a:schemeClr val="accent1"/>
+          </a:effectRef>
+          <a:fontRef idx="minor">
+            <a:schemeClr val="lt1"/>
+          </a:fontRef>
+        </p:style>
+        <p:txBody>
+          <a:bodyPr rtlCol="0" anchor="ctr"/>
+          <a:lstStyle/>
+          <a:p>
+            <a:pPr algn="ctr"/>
+          </a:p>
+        </p:txBody>
+      </p:sp>
+      <p:sp>
+        <p:nvSpPr>
+          <p:cNvPr id="3" name="Rectangle 2"/>
+          <p:cNvSpPr/>
+          <p:nvPr/>
+        </p:nvSpPr>
+        <p:spPr>
+          <a:xfrm>
+            <a:off x="502920" y="457200"/>
+            <a:ext cx="54864" cy="777240"/>
+          </a:xfrm>
+          <a:prstGeom prst="rect">
+            <a:avLst/>
+          </a:prstGeom>
+          <a:solidFill>
+            <a:srgbClr val="2563EB"/>
+          </a:solidFill>
+          <a:ln>
+            <a:noFill/>
+          </a:ln>
+          <a:effectLst/>
+        </p:spPr>
+        <p:style>
+          <a:lnRef idx="1">
+            <a:schemeClr val="accent1"/>
+          </a:lnRef>
+          <a:fillRef idx="3">
+            <a:schemeClr val="accent1"/>
+          </a:fillRef>
+          <a:effectRef idx="2">
+            <a:schemeClr val="accent1"/>
+          </a:effectRef>
+          <a:fontRef idx="minor">
+            <a:schemeClr val="lt1"/>
+          </a:fontRef>
+        </p:style>
+        <p:txBody>
+          <a:bodyPr rtlCol="0" anchor="ctr"/>
+          <a:lstStyle/>
+          <a:p>
+            <a:pPr algn="ctr"/>
+          </a:p>
+        </p:txBody>
+      </p:sp>
+      <p:sp>
+        <p:nvSpPr>
+          <p:cNvPr id="4" name="TextBox 3"/>
+          <p:cNvSpPr txBox="1"/>
+          <p:nvPr/>
+        </p:nvSpPr>
+        <p:spPr>
+          <a:xfrm>
+            <a:off x="713232" y="438912"/>
+            <a:ext cx="10058400" cy="274320"/>
+          </a:xfrm>
+          <a:prstGeom prst="rect">
+            <a:avLst/>
+          </a:prstGeom>
+          <a:noFill/>
+        </p:spPr>
+        <p:txBody>
+          <a:bodyPr wrap="none" lIns="0" tIns="0" rIns="0" bIns="0">
+            <a:spAutoFit/>
+          </a:bodyPr>
+          <a:lstStyle/>
+          <a:p>
+            <a:pPr algn="l"/>
+            <a:r>
+              <a:rPr sz="1150" b="1">
+                <a:solidFill>
+                  <a:srgbClr val="2563EB"/>
+                </a:solidFill>
+                <a:latin typeface="Segoe UI"/>
+              </a:rPr>
+              <a:t>ANNEXES</a:t>
+            </a:r>
+          </a:p>
+        </p:txBody>
+      </p:sp>
+      <p:sp>
+        <p:nvSpPr>
+          <p:cNvPr id="5" name="TextBox 4"/>
+          <p:cNvSpPr txBox="1"/>
+          <p:nvPr/>
+        </p:nvSpPr>
+        <p:spPr>
+          <a:xfrm>
+            <a:off x="685800" y="694944"/>
+            <a:ext cx="10789920" cy="594360"/>
+          </a:xfrm>
+          <a:prstGeom prst="rect">
+            <a:avLst/>
+          </a:prstGeom>
+          <a:noFill/>
+        </p:spPr>
+        <p:txBody>
+          <a:bodyPr wrap="square" lIns="0" tIns="0" rIns="0" bIns="0">
+            <a:spAutoFit/>
+          </a:bodyPr>
+          <a:lstStyle/>
+          <a:p>
+            <a:pPr algn="l"/>
+            <a:r>
+              <a:rPr sz="2400" b="1">
+                <a:solidFill>
+                  <a:srgbClr val="0F172A"/>
+                </a:solidFill>
+                <a:latin typeface="Segoe UI Semibold"/>
+              </a:rPr>
+              <a:t>Emploi du temps — créneaux, salles, réservations</a:t>
+            </a:r>
+          </a:p>
+        </p:txBody>
+      </p:sp>
+      <p:sp>
+        <p:nvSpPr>
+          <p:cNvPr id="6" name="TextBox 5"/>
+          <p:cNvSpPr txBox="1"/>
+          <p:nvPr/>
+        </p:nvSpPr>
+        <p:spPr>
+          <a:xfrm>
+            <a:off x="502920" y="6528816"/>
+            <a:ext cx="5486400" cy="274320"/>
+          </a:xfrm>
+          <a:prstGeom prst="rect">
+            <a:avLst/>
+          </a:prstGeom>
+          <a:noFill/>
+        </p:spPr>
+        <p:txBody>
+          <a:bodyPr wrap="none" lIns="0" tIns="0" rIns="0" bIns="0">
+            <a:spAutoFit/>
+          </a:bodyPr>
+          <a:lstStyle/>
+          <a:p>
+            <a:r>
+              <a:rPr sz="900">
+                <a:solidFill>
+                  <a:srgbClr val="64748B"/>
+                </a:solidFill>
+                <a:latin typeface="Segoe UI"/>
+              </a:rPr>
+              <a:t>TIRAHOU — Soutenance de mémoire</a:t>
+            </a:r>
+          </a:p>
+        </p:txBody>
+      </p:sp>
+      <p:sp>
+        <p:nvSpPr>
+          <p:cNvPr id="7" name="TextBox 6"/>
+          <p:cNvSpPr txBox="1"/>
+          <p:nvPr/>
+        </p:nvSpPr>
+        <p:spPr>
+          <a:xfrm>
+            <a:off x="10972800" y="6528816"/>
+            <a:ext cx="731520" cy="274320"/>
+          </a:xfrm>
+          <a:prstGeom prst="rect">
+            <a:avLst/>
+          </a:prstGeom>
+          <a:noFill/>
+        </p:spPr>
+        <p:txBody>
+          <a:bodyPr wrap="none" lIns="0" tIns="0" rIns="0" bIns="0">
+            <a:spAutoFit/>
+          </a:bodyPr>
+          <a:lstStyle/>
+          <a:p>
+            <a:pPr algn="r"/>
+            <a:r>
+              <a:rPr sz="900">
+                <a:solidFill>
+                  <a:srgbClr val="64748B"/>
+                </a:solidFill>
+                <a:latin typeface="Segoe UI"/>
+              </a:rPr>
+              <a:t>31</a:t>
+            </a:r>
+          </a:p>
+        </p:txBody>
+      </p:sp>
+      <p:cxnSp>
+        <p:nvCxnSpPr>
+          <p:cNvPr id="8" name="Connector 7"/>
+          <p:cNvCxnSpPr/>
+          <p:nvPr/>
+        </p:nvCxnSpPr>
+        <p:spPr>
+          <a:xfrm>
+            <a:off x="502920" y="6473952"/>
+            <a:ext cx="11183112" cy="0"/>
+          </a:xfrm>
+          <a:prstGeom prst="line">
+            <a:avLst/>
+          </a:prstGeom>
+          <a:ln w="9525">
+            <a:solidFill>
+              <a:srgbClr val="E2E8F0"/>
+            </a:solidFill>
+          </a:ln>
+        </p:spPr>
+        <p:style>
+          <a:lnRef idx="2">
+            <a:schemeClr val="accent1"/>
+          </a:lnRef>
+          <a:fillRef idx="0">
+            <a:schemeClr val="accent1"/>
+          </a:fillRef>
+          <a:effectRef idx="1">
+            <a:schemeClr val="accent1"/>
+          </a:effectRef>
+          <a:fontRef idx="minor">
+            <a:schemeClr val="tx1"/>
+          </a:fontRef>
+        </p:style>
+      </p:cxnSp>
+      <p:sp>
+        <p:nvSpPr>
+          <p:cNvPr id="9" name="Rounded Rectangle 8"/>
+          <p:cNvSpPr/>
+          <p:nvPr/>
+        </p:nvSpPr>
+        <p:spPr>
+          <a:xfrm>
+            <a:off x="4231177" y="1500000"/>
+            <a:ext cx="3726597" cy="4300000"/>
+          </a:xfrm>
+          <a:prstGeom prst="roundRect">
+            <a:avLst>
+              <a:gd name="adj" fmla="val 4500"/>
+            </a:avLst>
+          </a:prstGeom>
+          <a:solidFill>
+            <a:srgbClr val="FFFFFF"/>
+          </a:solidFill>
+          <a:ln w="12700">
+            <a:solidFill>
+              <a:srgbClr val="E2E8F0"/>
+            </a:solidFill>
+          </a:ln>
+          <a:effectLst/>
+        </p:spPr>
+        <p:style>
+          <a:lnRef idx="1">
+            <a:schemeClr val="accent1"/>
+          </a:lnRef>
+          <a:fillRef idx="3">
+            <a:schemeClr val="accent1"/>
+          </a:fillRef>
+          <a:effectRef idx="2">
+            <a:schemeClr val="accent1"/>
+          </a:effectRef>
+          <a:fontRef idx="minor">
+            <a:schemeClr val="lt1"/>
+          </a:fontRef>
+        </p:style>
+        <p:txBody>
+          <a:bodyPr rtlCol="0" anchor="ctr"/>
+          <a:lstStyle/>
+          <a:p>
+            <a:pPr algn="ctr"/>
+          </a:p>
+        </p:txBody>
+      </p:sp>
+      <p:pic>
+        <p:nvPicPr>
+          <p:cNvPr id="10" name="Picture 9" descr="24_EmploiTemps.png"/>
+          <p:cNvPicPr>
+            <a:picLocks noChangeAspect="1"/>
+          </p:cNvPicPr>
+          <p:nvPr/>
+        </p:nvPicPr>
+        <p:blipFill>
+          <a:blip r:embed="rId2"/>
+          <a:stretch>
+            <a:fillRect/>
+          </a:stretch>
+        </p:blipFill>
+        <p:spPr>
+          <a:xfrm>
+            <a:off x="4459777" y="1728600"/>
+            <a:ext cx="3269397" cy="3842800"/>
+          </a:xfrm>
+          <a:prstGeom prst="rect">
+            <a:avLst/>
+          </a:prstGeom>
+        </p:spPr>
+      </p:pic>
+      <p:sp>
+        <p:nvSpPr>
+          <p:cNvPr id="11" name="TextBox 10"/>
+          <p:cNvSpPr txBox="1"/>
+          <p:nvPr/>
+        </p:nvSpPr>
+        <p:spPr>
+          <a:xfrm>
+            <a:off x="502920" y="5950000"/>
+            <a:ext cx="11183112" cy="320000"/>
+          </a:xfrm>
+          <a:prstGeom prst="rect">
+            <a:avLst/>
+          </a:prstGeom>
+          <a:noFill/>
+        </p:spPr>
+        <p:txBody>
+          <a:bodyPr wrap="none" lIns="0" tIns="0" rIns="0" bIns="0">
+            <a:spAutoFit/>
+          </a:bodyPr>
+          <a:lstStyle/>
+          <a:p>
+            <a:pPr algn="ctr"/>
+            <a:r>
+              <a:rPr sz="1100" i="1">
+                <a:solidFill>
+                  <a:srgbClr val="64748B"/>
+                </a:solidFill>
+                <a:latin typeface="Segoe UI"/>
+              </a:rPr>
+              <a:t>Structure support de la planification des séances et de la gestion des salles (présentiel/hybride).</a:t>
             </a:r>
           </a:p>
         </p:txBody>

</xml_diff>